<commit_message>
chore(demos): ⬆️ FY26Q4 content refresh
- update to SPFx v1.23
- run through all exercise steps in associated MSLearn module to validate good working order
- updated steps & fixed typos where necessary
- updated slides where necessary
- update code samples to reflect MSLearn HOL exercise refresh & updates
- any & all users/names/company names/pictures/IDs are not real people/tenants... all are from M365 demo tenants provided by Microsoft
</commit_message>
<xml_diff>
--- a/01-intro.pptx
+++ b/01-intro.pptx
@@ -2479,13 +2479,13 @@
         <a:lstStyle/>
         <a:p>
           <a:r>
-            <a:rPr lang="en-US" sz="1600" baseline="0" dirty="0">
+            <a:rPr lang="en-US" sz="2400" baseline="0" dirty="0">
               <a:latin typeface="Courier New" panose="02070309020205020404" pitchFamily="49" charset="0"/>
               <a:cs typeface="Courier New" panose="02070309020205020404" pitchFamily="49" charset="0"/>
             </a:rPr>
-            <a:t>gulp build</a:t>
+            <a:t>heft build</a:t>
           </a:r>
-          <a:endParaRPr lang="en-US" sz="1600" dirty="0">
+          <a:endParaRPr lang="en-US" sz="2400" dirty="0">
             <a:latin typeface="Courier New" panose="02070309020205020404" pitchFamily="49" charset="0"/>
             <a:cs typeface="Courier New" panose="02070309020205020404" pitchFamily="49" charset="0"/>
           </a:endParaRPr>
@@ -2678,13 +2678,13 @@
         <a:lstStyle/>
         <a:p>
           <a:r>
-            <a:rPr lang="en-US" sz="1600" baseline="0" dirty="0">
+            <a:rPr lang="en-US" sz="2000" baseline="0" dirty="0">
               <a:latin typeface="Courier New" panose="02070309020205020404" pitchFamily="49" charset="0"/>
               <a:cs typeface="Courier New" panose="02070309020205020404" pitchFamily="49" charset="0"/>
             </a:rPr>
-            <a:t>gulp bundle [--ship | -p]</a:t>
+            <a:t>Included as part of the heft build</a:t>
           </a:r>
-          <a:endParaRPr lang="en-US" sz="2200" dirty="0">
+          <a:endParaRPr lang="en-US" sz="2800" dirty="0">
             <a:latin typeface="Courier New" panose="02070309020205020404" pitchFamily="49" charset="0"/>
             <a:cs typeface="Courier New" panose="02070309020205020404" pitchFamily="49" charset="0"/>
           </a:endParaRPr>
@@ -2877,10 +2877,13 @@
         <a:lstStyle/>
         <a:p>
           <a:r>
-            <a:rPr lang="en-US" sz="1600" baseline="0" dirty="0"/>
-            <a:t>gulp package-solution [--ship | -p]</a:t>
+            <a:rPr lang="en-US" sz="1800" baseline="0" dirty="0">
+              <a:latin typeface="Courier New" panose="02070309020205020404" pitchFamily="49" charset="0"/>
+              <a:cs typeface="Courier New" panose="02070309020205020404" pitchFamily="49" charset="0"/>
+            </a:rPr>
+            <a:t>heft package-solution</a:t>
           </a:r>
-          <a:endParaRPr lang="en-US" sz="2200" dirty="0"/>
+          <a:endParaRPr lang="en-US" sz="2400" dirty="0"/>
         </a:p>
       </dgm:t>
     </dgm:pt>
@@ -3071,7 +3074,15 @@
         <a:p>
           <a:r>
             <a:rPr lang="en-US" sz="2200" baseline="0" dirty="0"/>
-            <a:t>Files added to /lib folder</a:t>
+            <a:t>Files added to /lib &amp; /lib-</a:t>
+          </a:r>
+          <a:r>
+            <a:rPr lang="en-US" sz="2200" baseline="0" dirty="0" err="1"/>
+            <a:t>commonjs</a:t>
+          </a:r>
+          <a:r>
+            <a:rPr lang="en-US" sz="2200" baseline="0" dirty="0"/>
+            <a:t> folder</a:t>
           </a:r>
           <a:endParaRPr lang="en-US" sz="2200" dirty="0"/>
         </a:p>
@@ -3197,15 +3208,15 @@
     <dgm:cxn modelId="{BA45D132-B22A-E241-A492-626F11536B69}" type="presOf" srcId="{2D3B96C6-1E1C-7240-98B3-69ED9FA9FCDA}" destId="{2C4520AC-9D4A-BC47-AFD0-546668CFEF6C}" srcOrd="0" destOrd="1" presId="urn:microsoft.com/office/officeart/2005/8/layout/hList1"/>
     <dgm:cxn modelId="{5102D93C-2AC1-8345-B36E-252498EDC9BE}" srcId="{0EBBACFB-224E-6B4B-909A-2816577CED77}" destId="{FF0B3A82-6073-1D40-8151-20E19DA82546}" srcOrd="0" destOrd="0" parTransId="{A3D9A9F6-472D-6F47-A359-02DA8FBEF969}" sibTransId="{441CA8A1-4F1D-4348-90AB-1BE42DC126E6}"/>
     <dgm:cxn modelId="{693AE93F-89A5-2C4E-8468-0C79900E2C9F}" type="presOf" srcId="{356BA6F2-DA31-A74F-B748-FAD9B63702F7}" destId="{76F2FD95-1575-944F-B97E-E290885EA905}" srcOrd="0" destOrd="0" presId="urn:microsoft.com/office/officeart/2005/8/layout/hList1"/>
-    <dgm:cxn modelId="{260E3062-E808-DD4B-B5D4-AAE403390DA2}" type="presOf" srcId="{0A40D671-F6BE-EB44-9974-5A3E60D66181}" destId="{2C4520AC-9D4A-BC47-AFD0-546668CFEF6C}" srcOrd="0" destOrd="3" presId="urn:microsoft.com/office/officeart/2005/8/layout/hList1"/>
-    <dgm:cxn modelId="{FB0FCF63-EDCE-C540-A9C7-9423B96372EC}" srcId="{880506F6-0F9F-1644-802C-4BA1599DF55A}" destId="{356BA6F2-DA31-A74F-B748-FAD9B63702F7}" srcOrd="1" destOrd="0" parTransId="{0C12A86F-200D-6B45-9AA6-C5A3B390EDD9}" sibTransId="{26C89A25-AFB3-1742-B2F1-E9B386F2DB15}"/>
     <dgm:cxn modelId="{03E72F48-C275-5A4A-9765-E2E1DE141062}" type="presOf" srcId="{FF0B3A82-6073-1D40-8151-20E19DA82546}" destId="{2C4520AC-9D4A-BC47-AFD0-546668CFEF6C}" srcOrd="0" destOrd="0" presId="urn:microsoft.com/office/officeart/2005/8/layout/hList1"/>
     <dgm:cxn modelId="{D441664A-B1DA-8A49-A3B6-40D6A5DC1134}" type="presOf" srcId="{6EB2E288-3D12-E54D-A023-D2C643A5FFC6}" destId="{94701F3D-C5AB-ED43-A43A-96F1573EBFF4}" srcOrd="0" destOrd="1" presId="urn:microsoft.com/office/officeart/2005/8/layout/hList1"/>
     <dgm:cxn modelId="{536FA94B-A04A-1D4C-A03F-1EC5ADD50949}" srcId="{0EBBACFB-224E-6B4B-909A-2816577CED77}" destId="{8D160A57-840F-7B48-93F3-0C3801F7CBF7}" srcOrd="4" destOrd="0" parTransId="{817A9263-06C2-8F4F-97F9-EBB85DF2FCB1}" sibTransId="{9F6B8907-5C16-224A-89E5-8BA7202AE319}"/>
+    <dgm:cxn modelId="{AA211854-FB14-914D-AAE3-198F99292829}" srcId="{C47B14EB-3D25-0A42-8C11-6DFAFA4CE412}" destId="{DC2300DB-A572-BC4D-AC01-801CE0C4FC98}" srcOrd="0" destOrd="0" parTransId="{1E819D1C-D9C5-0548-B6D8-DC0104AEED47}" sibTransId="{B5ED62F5-43DC-594F-905D-B3D7F45BE8B8}"/>
+    <dgm:cxn modelId="{E3EDF654-B822-D244-BCF6-19CBEF902D1A}" srcId="{356BA6F2-DA31-A74F-B748-FAD9B63702F7}" destId="{6DC1113A-C09E-244B-B754-AEF7DC4E0D1F}" srcOrd="0" destOrd="0" parTransId="{E5760176-7B56-E64B-9AEC-284624ADE1CA}" sibTransId="{986660AA-50C9-7348-B7BA-1D54061D3A69}"/>
+    <dgm:cxn modelId="{260E3062-E808-DD4B-B5D4-AAE403390DA2}" type="presOf" srcId="{0A40D671-F6BE-EB44-9974-5A3E60D66181}" destId="{2C4520AC-9D4A-BC47-AFD0-546668CFEF6C}" srcOrd="0" destOrd="3" presId="urn:microsoft.com/office/officeart/2005/8/layout/hList1"/>
+    <dgm:cxn modelId="{FB0FCF63-EDCE-C540-A9C7-9423B96372EC}" srcId="{880506F6-0F9F-1644-802C-4BA1599DF55A}" destId="{356BA6F2-DA31-A74F-B748-FAD9B63702F7}" srcOrd="1" destOrd="0" parTransId="{0C12A86F-200D-6B45-9AA6-C5A3B390EDD9}" sibTransId="{26C89A25-AFB3-1742-B2F1-E9B386F2DB15}"/>
     <dgm:cxn modelId="{F83BD66F-75A5-7644-947D-004A8161C6A5}" type="presOf" srcId="{DC2300DB-A572-BC4D-AC01-801CE0C4FC98}" destId="{94701F3D-C5AB-ED43-A43A-96F1573EBFF4}" srcOrd="0" destOrd="0" presId="urn:microsoft.com/office/officeart/2005/8/layout/hList1"/>
     <dgm:cxn modelId="{1885C473-4105-2441-97E1-5A2CDC8D8CEF}" type="presOf" srcId="{C47B14EB-3D25-0A42-8C11-6DFAFA4CE412}" destId="{55DA91CA-40A7-F24E-8912-D4AAE15E7451}" srcOrd="0" destOrd="0" presId="urn:microsoft.com/office/officeart/2005/8/layout/hList1"/>
-    <dgm:cxn modelId="{AA211854-FB14-914D-AAE3-198F99292829}" srcId="{C47B14EB-3D25-0A42-8C11-6DFAFA4CE412}" destId="{DC2300DB-A572-BC4D-AC01-801CE0C4FC98}" srcOrd="0" destOrd="0" parTransId="{1E819D1C-D9C5-0548-B6D8-DC0104AEED47}" sibTransId="{B5ED62F5-43DC-594F-905D-B3D7F45BE8B8}"/>
-    <dgm:cxn modelId="{E3EDF654-B822-D244-BCF6-19CBEF902D1A}" srcId="{356BA6F2-DA31-A74F-B748-FAD9B63702F7}" destId="{6DC1113A-C09E-244B-B754-AEF7DC4E0D1F}" srcOrd="0" destOrd="0" parTransId="{E5760176-7B56-E64B-9AEC-284624ADE1CA}" sibTransId="{986660AA-50C9-7348-B7BA-1D54061D3A69}"/>
     <dgm:cxn modelId="{A20D947C-37FE-C040-B684-32AE893755C4}" srcId="{C47B14EB-3D25-0A42-8C11-6DFAFA4CE412}" destId="{C8CCF840-4DCA-124E-B442-189DDE6E6D85}" srcOrd="4" destOrd="0" parTransId="{5AC6A237-BA25-604D-A7ED-E12EE8BAC57A}" sibTransId="{CA7476F4-6D50-EC4E-AB5C-D1803D2EF5E3}"/>
     <dgm:cxn modelId="{1A554A99-C17A-FB4F-8B93-A8E5B8D4CAFB}" srcId="{356BA6F2-DA31-A74F-B748-FAD9B63702F7}" destId="{F055A004-3C1D-0D40-9BBD-619BA986A0F9}" srcOrd="3" destOrd="0" parTransId="{664AFBB3-7A85-C148-B66C-A75F55E45DDB}" sibTransId="{41A3ADCB-B632-B041-ACFC-E92D555B74C1}"/>
     <dgm:cxn modelId="{4F982D9F-05A1-F643-86F6-27306EFB2DC6}" type="presOf" srcId="{C8CCF840-4DCA-124E-B442-189DDE6E6D85}" destId="{94701F3D-C5AB-ED43-A43A-96F1573EBFF4}" srcOrd="0" destOrd="4" presId="urn:microsoft.com/office/officeart/2005/8/layout/hList1"/>
@@ -3757,10 +3768,10 @@
     <dgm:cxn modelId="{359BFA01-0E83-FF4E-96ED-953EB372D29A}" srcId="{7DB09EC8-FD25-E145-8CE2-BF16481AF541}" destId="{E167859A-E813-044A-B3AB-6CA3F2586A8E}" srcOrd="2" destOrd="0" parTransId="{E16C9E97-5E6E-2A4A-93BB-279A1C49C9AF}" sibTransId="{23AC9937-853F-C949-89D9-566D6EE19C95}"/>
     <dgm:cxn modelId="{26D58E14-D724-C64B-8EE9-AD59DB65C323}" type="presOf" srcId="{9781AD9A-F44F-824E-9C6C-5448DE1CB4AA}" destId="{EDE7B1CE-9F65-5145-BD39-D2B7300D4AEA}" srcOrd="0" destOrd="3" presId="urn:microsoft.com/office/officeart/2005/8/layout/hList1"/>
     <dgm:cxn modelId="{13E5E816-B312-324E-B588-49848029E8F1}" srcId="{06F94589-FF43-C847-A40C-95C8A0F2098F}" destId="{1303F77A-823B-F24F-BC8C-44EE34194DAA}" srcOrd="2" destOrd="0" parTransId="{B8468FF1-35BC-F740-AC9A-188460C6810A}" sibTransId="{3288F804-8F4C-CF43-AF6A-1640D6F0FB89}"/>
+    <dgm:cxn modelId="{72BD105A-491B-6248-8040-6008BF192949}" type="presOf" srcId="{0BD9C940-EE39-9243-B135-9158DE22D1B8}" destId="{BA0B0F0D-C1A2-A543-9D81-E0023AD41733}" srcOrd="0" destOrd="1" presId="urn:microsoft.com/office/officeart/2005/8/layout/hList1"/>
     <dgm:cxn modelId="{B08EA261-B055-8348-9222-12A91F818528}" type="presOf" srcId="{E167859A-E813-044A-B3AB-6CA3F2586A8E}" destId="{EDE7B1CE-9F65-5145-BD39-D2B7300D4AEA}" srcOrd="0" destOrd="2" presId="urn:microsoft.com/office/officeart/2005/8/layout/hList1"/>
     <dgm:cxn modelId="{44F33762-329C-3340-A556-53840FAAA87A}" srcId="{7DB09EC8-FD25-E145-8CE2-BF16481AF541}" destId="{9580C340-CAEA-564F-B7F8-C85D2F4A66BC}" srcOrd="1" destOrd="0" parTransId="{5E89A9CD-413D-564F-9549-A1B435C07A30}" sibTransId="{5D5F9B31-0ED8-FD4A-AEFB-F07E13BD65C2}"/>
     <dgm:cxn modelId="{33E4E874-5CE4-E54E-90A1-28CC93151E38}" type="presOf" srcId="{1303F77A-823B-F24F-BC8C-44EE34194DAA}" destId="{BA0B0F0D-C1A2-A543-9D81-E0023AD41733}" srcOrd="0" destOrd="2" presId="urn:microsoft.com/office/officeart/2005/8/layout/hList1"/>
-    <dgm:cxn modelId="{72BD105A-491B-6248-8040-6008BF192949}" type="presOf" srcId="{0BD9C940-EE39-9243-B135-9158DE22D1B8}" destId="{BA0B0F0D-C1A2-A543-9D81-E0023AD41733}" srcOrd="0" destOrd="1" presId="urn:microsoft.com/office/officeart/2005/8/layout/hList1"/>
     <dgm:cxn modelId="{A71E7587-0D4B-1E42-88A1-8354128901C6}" type="presOf" srcId="{CD08757C-4D54-D646-99F0-41F3AA9ACAB1}" destId="{EDE7B1CE-9F65-5145-BD39-D2B7300D4AEA}" srcOrd="0" destOrd="4" presId="urn:microsoft.com/office/officeart/2005/8/layout/hList1"/>
     <dgm:cxn modelId="{21C4A98C-CE46-E642-858F-CC43D91BB966}" srcId="{E5A3B105-6DDB-1048-9FF0-770C9E4B6699}" destId="{7DB09EC8-FD25-E145-8CE2-BF16481AF541}" srcOrd="1" destOrd="0" parTransId="{D5F3623E-3A11-DF45-A2BE-8BF9B2CB3F8C}" sibTransId="{F9D52172-6533-134F-B06E-639A86C4F608}"/>
     <dgm:cxn modelId="{B46B4191-4C89-BE41-8718-0E7AC9344C3E}" srcId="{06F94589-FF43-C847-A40C-95C8A0F2098F}" destId="{5C57599B-9A0A-E041-BDB5-E42D0883B734}" srcOrd="4" destOrd="0" parTransId="{E4906946-6C40-7540-902D-C93F589267A3}" sibTransId="{51EE859E-0E50-0B43-A523-A84E0F6A33CA}"/>
@@ -4346,8 +4357,8 @@
     <dgm:cxn modelId="{C5731229-423F-0A40-8697-FDB45A2FE7EE}" srcId="{7EBF4009-A9A6-5A44-B3C9-B43FC11DC5DA}" destId="{2936C287-6849-2D47-9F34-1559699D2FE4}" srcOrd="0" destOrd="0" parTransId="{DAB63FA4-13F3-F442-A848-B226281CF076}" sibTransId="{BE4A322B-57C7-FF4B-B4D4-F0D55A7FD288}"/>
     <dgm:cxn modelId="{B80E5035-F269-3849-955B-DE7ADAA9FC36}" srcId="{D9C02B27-90A5-4447-8F97-CA1FF4020D33}" destId="{7EBF4009-A9A6-5A44-B3C9-B43FC11DC5DA}" srcOrd="2" destOrd="0" parTransId="{A30BF236-3D51-9D4F-88D5-71515F8119ED}" sibTransId="{FAFFAF87-6B97-8E46-9777-0749931E2F2B}"/>
     <dgm:cxn modelId="{12CA5B43-61CF-0B4A-82DB-62D6FDA20E33}" type="presOf" srcId="{D6BDA6D3-B53B-8A4D-AA13-843AD4F48615}" destId="{D590C922-94BA-9F4D-B8F8-A8E428A9D936}" srcOrd="0" destOrd="4" presId="urn:microsoft.com/office/officeart/2005/8/layout/vList2"/>
+    <dgm:cxn modelId="{B8DE8851-F7C1-FB42-A83C-BFD0783405C3}" type="presOf" srcId="{25FDB71C-6DE1-C942-A0FC-22E8CF8B5E0A}" destId="{D590C922-94BA-9F4D-B8F8-A8E428A9D936}" srcOrd="0" destOrd="7" presId="urn:microsoft.com/office/officeart/2005/8/layout/vList2"/>
     <dgm:cxn modelId="{CD26B664-0725-864D-A546-F0C6FD9E50BD}" type="presOf" srcId="{5D430FDB-4F7F-BD4F-A8A2-ACE3B19E5491}" destId="{71E57A2F-7FFD-0640-81DE-62B470CD78FC}" srcOrd="0" destOrd="1" presId="urn:microsoft.com/office/officeart/2005/8/layout/vList2"/>
-    <dgm:cxn modelId="{B8DE8851-F7C1-FB42-A83C-BFD0783405C3}" type="presOf" srcId="{25FDB71C-6DE1-C942-A0FC-22E8CF8B5E0A}" destId="{D590C922-94BA-9F4D-B8F8-A8E428A9D936}" srcOrd="0" destOrd="7" presId="urn:microsoft.com/office/officeart/2005/8/layout/vList2"/>
     <dgm:cxn modelId="{7870C879-A540-1B41-BB4D-F8E5A852EA21}" srcId="{7C2F12C8-AAC5-0946-8C31-3D66181674BC}" destId="{CDAF1557-FB57-1B4F-9A30-DF2781A7EC13}" srcOrd="0" destOrd="0" parTransId="{1CD1455C-B4E9-B948-97CB-8030B6BBD61D}" sibTransId="{037DE8BC-6AE0-4940-A600-ADE5C3D93EF9}"/>
     <dgm:cxn modelId="{BF8E4F7B-0A44-9B41-9465-2B7608CA6FC0}" type="presOf" srcId="{7C2F12C8-AAC5-0946-8C31-3D66181674BC}" destId="{54E3C766-1B43-6F43-8ADC-A212F4EDFF69}" srcOrd="0" destOrd="0" presId="urn:microsoft.com/office/officeart/2005/8/layout/vList2"/>
     <dgm:cxn modelId="{49E2007C-38CC-364D-95AB-5521E0C219CA}" srcId="{10505F77-3304-374E-AE8F-0790E0912397}" destId="{7F6822FB-2DC8-D648-A9A4-9DD60DE95D50}" srcOrd="1" destOrd="0" parTransId="{84ACAC37-E2E2-0545-856D-931C01570186}" sibTransId="{9F22BB0C-5AE5-F940-9A70-23415763B841}"/>
@@ -4390,8 +4401,8 @@
       </dsp:nvSpPr>
       <dsp:spPr>
         <a:xfrm>
-          <a:off x="3616" y="69853"/>
-          <a:ext cx="3526453" cy="1398900"/>
+          <a:off x="3616" y="66429"/>
+          <a:ext cx="3526453" cy="1387219"/>
         </a:xfrm>
         <a:prstGeom prst="rect">
           <a:avLst/>
@@ -4457,8 +4468,8 @@
         </a:p>
       </dsp:txBody>
       <dsp:txXfrm>
-        <a:off x="3616" y="69853"/>
-        <a:ext cx="3526453" cy="1398900"/>
+        <a:off x="3616" y="66429"/>
+        <a:ext cx="3526453" cy="1387219"/>
       </dsp:txXfrm>
     </dsp:sp>
     <dsp:sp modelId="{94701F3D-C5AB-ED43-A43A-96F1573EBFF4}">
@@ -4468,8 +4479,8 @@
       </dsp:nvSpPr>
       <dsp:spPr>
         <a:xfrm>
-          <a:off x="3616" y="1468753"/>
-          <a:ext cx="3526453" cy="3752071"/>
+          <a:off x="3616" y="1453649"/>
+          <a:ext cx="3526453" cy="3770600"/>
         </a:xfrm>
         <a:prstGeom prst="rect">
           <a:avLst/>
@@ -4512,12 +4523,12 @@
         <a:fontRef idx="minor"/>
       </dsp:style>
       <dsp:txBody>
-        <a:bodyPr spcFirstLastPara="0" vert="horz" wrap="square" lIns="85344" tIns="85344" rIns="113792" bIns="128016" numCol="1" spcCol="1270" anchor="t" anchorCtr="0">
+        <a:bodyPr spcFirstLastPara="0" vert="horz" wrap="square" lIns="128016" tIns="128016" rIns="170688" bIns="192024" numCol="1" spcCol="1270" anchor="t" anchorCtr="0">
           <a:noAutofit/>
         </a:bodyPr>
         <a:lstStyle/>
         <a:p>
-          <a:pPr marL="171450" lvl="1" indent="-171450" algn="l" defTabSz="711200">
+          <a:pPr marL="228600" lvl="1" indent="-228600" algn="l" defTabSz="1066800">
             <a:lnSpc>
               <a:spcPct val="90000"/>
             </a:lnSpc>
@@ -4530,13 +4541,13 @@
             <a:buChar char="•"/>
           </a:pPr>
           <a:r>
-            <a:rPr lang="en-US" sz="1600" kern="1200" baseline="0" dirty="0">
+            <a:rPr lang="en-US" sz="2400" kern="1200" baseline="0" dirty="0">
               <a:latin typeface="Courier New" panose="02070309020205020404" pitchFamily="49" charset="0"/>
               <a:cs typeface="Courier New" panose="02070309020205020404" pitchFamily="49" charset="0"/>
             </a:rPr>
-            <a:t>gulp build</a:t>
+            <a:t>heft build</a:t>
           </a:r>
-          <a:endParaRPr lang="en-US" sz="1600" kern="1200" dirty="0">
+          <a:endParaRPr lang="en-US" sz="2400" kern="1200" dirty="0">
             <a:latin typeface="Courier New" panose="02070309020205020404" pitchFamily="49" charset="0"/>
             <a:cs typeface="Courier New" panose="02070309020205020404" pitchFamily="49" charset="0"/>
           </a:endParaRPr>
@@ -4621,14 +4632,22 @@
           </a:pPr>
           <a:r>
             <a:rPr lang="en-US" sz="2200" kern="1200" baseline="0" dirty="0"/>
-            <a:t>Files added to /lib folder</a:t>
+            <a:t>Files added to /lib &amp; /lib-</a:t>
+          </a:r>
+          <a:r>
+            <a:rPr lang="en-US" sz="2200" kern="1200" baseline="0" dirty="0" err="1"/>
+            <a:t>commonjs</a:t>
+          </a:r>
+          <a:r>
+            <a:rPr lang="en-US" sz="2200" kern="1200" baseline="0" dirty="0"/>
+            <a:t> folder</a:t>
           </a:r>
           <a:endParaRPr lang="en-US" sz="2200" kern="1200" dirty="0"/>
         </a:p>
       </dsp:txBody>
       <dsp:txXfrm>
-        <a:off x="3616" y="1468753"/>
-        <a:ext cx="3526453" cy="3752071"/>
+        <a:off x="3616" y="1453649"/>
+        <a:ext cx="3526453" cy="3770600"/>
       </dsp:txXfrm>
     </dsp:sp>
     <dsp:sp modelId="{76F2FD95-1575-944F-B97E-E290885EA905}">
@@ -4638,8 +4657,8 @@
       </dsp:nvSpPr>
       <dsp:spPr>
         <a:xfrm>
-          <a:off x="4023773" y="69853"/>
-          <a:ext cx="3526453" cy="1398900"/>
+          <a:off x="4023773" y="66429"/>
+          <a:ext cx="3526453" cy="1387219"/>
         </a:xfrm>
         <a:prstGeom prst="rect">
           <a:avLst/>
@@ -4705,8 +4724,8 @@
         </a:p>
       </dsp:txBody>
       <dsp:txXfrm>
-        <a:off x="4023773" y="69853"/>
-        <a:ext cx="3526453" cy="1398900"/>
+        <a:off x="4023773" y="66429"/>
+        <a:ext cx="3526453" cy="1387219"/>
       </dsp:txXfrm>
     </dsp:sp>
     <dsp:sp modelId="{35D0C4CB-977A-234C-8250-7907B6A18896}">
@@ -4716,8 +4735,8 @@
       </dsp:nvSpPr>
       <dsp:spPr>
         <a:xfrm>
-          <a:off x="4023773" y="1468753"/>
-          <a:ext cx="3526453" cy="3752071"/>
+          <a:off x="4023773" y="1453649"/>
+          <a:ext cx="3526453" cy="3770600"/>
         </a:xfrm>
         <a:prstGeom prst="rect">
           <a:avLst/>
@@ -4760,12 +4779,12 @@
         <a:fontRef idx="minor"/>
       </dsp:style>
       <dsp:txBody>
-        <a:bodyPr spcFirstLastPara="0" vert="horz" wrap="square" lIns="85344" tIns="85344" rIns="113792" bIns="128016" numCol="1" spcCol="1270" anchor="t" anchorCtr="0">
+        <a:bodyPr spcFirstLastPara="0" vert="horz" wrap="square" lIns="106680" tIns="106680" rIns="142240" bIns="160020" numCol="1" spcCol="1270" anchor="t" anchorCtr="0">
           <a:noAutofit/>
         </a:bodyPr>
         <a:lstStyle/>
         <a:p>
-          <a:pPr marL="171450" lvl="1" indent="-171450" algn="l" defTabSz="711200">
+          <a:pPr marL="228600" lvl="1" indent="-228600" algn="l" defTabSz="889000">
             <a:lnSpc>
               <a:spcPct val="90000"/>
             </a:lnSpc>
@@ -4778,13 +4797,13 @@
             <a:buChar char="•"/>
           </a:pPr>
           <a:r>
-            <a:rPr lang="en-US" sz="1600" kern="1200" baseline="0" dirty="0">
+            <a:rPr lang="en-US" sz="2000" kern="1200" baseline="0" dirty="0">
               <a:latin typeface="Courier New" panose="02070309020205020404" pitchFamily="49" charset="0"/>
               <a:cs typeface="Courier New" panose="02070309020205020404" pitchFamily="49" charset="0"/>
             </a:rPr>
-            <a:t>gulp bundle [--ship | -p]</a:t>
+            <a:t>Included as part of the heft build</a:t>
           </a:r>
-          <a:endParaRPr lang="en-US" sz="2200" kern="1200" dirty="0">
+          <a:endParaRPr lang="en-US" sz="2800" kern="1200" dirty="0">
             <a:latin typeface="Courier New" panose="02070309020205020404" pitchFamily="49" charset="0"/>
             <a:cs typeface="Courier New" panose="02070309020205020404" pitchFamily="49" charset="0"/>
           </a:endParaRPr>
@@ -4856,8 +4875,8 @@
         </a:p>
       </dsp:txBody>
       <dsp:txXfrm>
-        <a:off x="4023773" y="1468753"/>
-        <a:ext cx="3526453" cy="3752071"/>
+        <a:off x="4023773" y="1453649"/>
+        <a:ext cx="3526453" cy="3770600"/>
       </dsp:txXfrm>
     </dsp:sp>
     <dsp:sp modelId="{B18F7E79-C1EE-C147-B91F-863D979C5188}">
@@ -4867,8 +4886,8 @@
       </dsp:nvSpPr>
       <dsp:spPr>
         <a:xfrm>
-          <a:off x="8043930" y="69853"/>
-          <a:ext cx="3526453" cy="1398900"/>
+          <a:off x="8043930" y="66429"/>
+          <a:ext cx="3526453" cy="1387219"/>
         </a:xfrm>
         <a:prstGeom prst="rect">
           <a:avLst/>
@@ -4934,8 +4953,8 @@
         </a:p>
       </dsp:txBody>
       <dsp:txXfrm>
-        <a:off x="8043930" y="69853"/>
-        <a:ext cx="3526453" cy="1398900"/>
+        <a:off x="8043930" y="66429"/>
+        <a:ext cx="3526453" cy="1387219"/>
       </dsp:txXfrm>
     </dsp:sp>
     <dsp:sp modelId="{2C4520AC-9D4A-BC47-AFD0-546668CFEF6C}">
@@ -4945,8 +4964,8 @@
       </dsp:nvSpPr>
       <dsp:spPr>
         <a:xfrm>
-          <a:off x="8043930" y="1468753"/>
-          <a:ext cx="3526453" cy="3752071"/>
+          <a:off x="8043930" y="1453649"/>
+          <a:ext cx="3526453" cy="3770600"/>
         </a:xfrm>
         <a:prstGeom prst="rect">
           <a:avLst/>
@@ -4989,12 +5008,12 @@
         <a:fontRef idx="minor"/>
       </dsp:style>
       <dsp:txBody>
-        <a:bodyPr spcFirstLastPara="0" vert="horz" wrap="square" lIns="85344" tIns="85344" rIns="113792" bIns="128016" numCol="1" spcCol="1270" anchor="t" anchorCtr="0">
+        <a:bodyPr spcFirstLastPara="0" vert="horz" wrap="square" lIns="96012" tIns="96012" rIns="128016" bIns="144018" numCol="1" spcCol="1270" anchor="t" anchorCtr="0">
           <a:noAutofit/>
         </a:bodyPr>
         <a:lstStyle/>
         <a:p>
-          <a:pPr marL="171450" lvl="1" indent="-171450" algn="l" defTabSz="711200">
+          <a:pPr marL="171450" lvl="1" indent="-171450" algn="l" defTabSz="800100">
             <a:lnSpc>
               <a:spcPct val="90000"/>
             </a:lnSpc>
@@ -5007,10 +5026,13 @@
             <a:buChar char="•"/>
           </a:pPr>
           <a:r>
-            <a:rPr lang="en-US" sz="1600" kern="1200" baseline="0" dirty="0"/>
-            <a:t>gulp package-solution [--ship | -p]</a:t>
+            <a:rPr lang="en-US" sz="1800" kern="1200" baseline="0" dirty="0">
+              <a:latin typeface="Courier New" panose="02070309020205020404" pitchFamily="49" charset="0"/>
+              <a:cs typeface="Courier New" panose="02070309020205020404" pitchFamily="49" charset="0"/>
+            </a:rPr>
+            <a:t>heft package-solution</a:t>
           </a:r>
-          <a:endParaRPr lang="en-US" sz="2200" kern="1200" dirty="0"/>
+          <a:endParaRPr lang="en-US" sz="2400" kern="1200" dirty="0"/>
         </a:p>
         <a:p>
           <a:pPr marL="228600" lvl="1" indent="-228600" algn="l" defTabSz="977900">
@@ -5098,8 +5120,8 @@
         </a:p>
       </dsp:txBody>
       <dsp:txXfrm>
-        <a:off x="8043930" y="1468753"/>
-        <a:ext cx="3526453" cy="3752071"/>
+        <a:off x="8043930" y="1453649"/>
+        <a:ext cx="3526453" cy="3770600"/>
       </dsp:txXfrm>
     </dsp:sp>
   </dsp:spTree>
@@ -9829,7 +9851,7 @@
               <a:rPr lang="en-US" smtClean="0">
                 <a:latin typeface="Segoe UI" pitchFamily="34" charset="0"/>
               </a:rPr>
-              <a:t>11/19/2022 4:11 PM</a:t>
+              <a:t>5/25/26 3:44 PM</a:t>
             </a:fld>
             <a:endParaRPr lang="en-US" dirty="0">
               <a:latin typeface="Segoe UI" pitchFamily="34" charset="0"/>
@@ -10126,7 +10148,7 @@
           <a:p>
             <a:fld id="{D18B56EA-E28F-4F92-9F16-7A6F2501B303}" type="datetime8">
               <a:rPr lang="en-US" smtClean="0"/>
-              <a:t>11/19/2022 4:11 PM</a:t>
+              <a:t>5/25/26 3:44 PM</a:t>
             </a:fld>
             <a:endParaRPr lang="en-US" dirty="0"/>
           </a:p>
@@ -10415,7 +10437,7 @@
           <a:bodyPr/>
           <a:lstStyle/>
           <a:p>
-            <a:endParaRPr lang="en-US"/>
+            <a:endParaRPr lang="en-US" dirty="0"/>
           </a:p>
         </p:txBody>
       </p:sp>
@@ -10509,7 +10531,7 @@
           <a:p>
             <a:fld id="{D18B56EA-E28F-4F92-9F16-7A6F2501B303}" type="datetime8">
               <a:rPr lang="en-US" smtClean="0"/>
-              <a:t>11/19/2022 4:11 PM</a:t>
+              <a:t>5/25/26 3:44 PM</a:t>
             </a:fld>
             <a:endParaRPr lang="en-US" dirty="0"/>
           </a:p>
@@ -10690,7 +10712,7 @@
           <a:p>
             <a:fld id="{D18B56EA-E28F-4F92-9F16-7A6F2501B303}" type="datetime8">
               <a:rPr lang="en-US" smtClean="0"/>
-              <a:t>11/19/2022 4:11 PM</a:t>
+              <a:t>5/25/26 3:44 PM</a:t>
             </a:fld>
             <a:endParaRPr lang="en-US" dirty="0"/>
           </a:p>
@@ -10871,7 +10893,7 @@
           <a:p>
             <a:fld id="{D18B56EA-E28F-4F92-9F16-7A6F2501B303}" type="datetime8">
               <a:rPr lang="en-US" smtClean="0"/>
-              <a:t>11/19/2022 4:11 PM</a:t>
+              <a:t>5/25/26 3:44 PM</a:t>
             </a:fld>
             <a:endParaRPr lang="en-US" dirty="0"/>
           </a:p>
@@ -11052,7 +11074,7 @@
           <a:p>
             <a:fld id="{D18B56EA-E28F-4F92-9F16-7A6F2501B303}" type="datetime8">
               <a:rPr lang="en-US" smtClean="0"/>
-              <a:t>11/19/2022 4:11 PM</a:t>
+              <a:t>5/25/26 3:44 PM</a:t>
             </a:fld>
             <a:endParaRPr lang="en-US" dirty="0"/>
           </a:p>
@@ -11236,7 +11258,7 @@
           <a:p>
             <a:fld id="{D18B56EA-E28F-4F92-9F16-7A6F2501B303}" type="datetime8">
               <a:rPr lang="en-US" smtClean="0"/>
-              <a:t>11/19/2022 4:11 PM</a:t>
+              <a:t>5/25/26 3:44 PM</a:t>
             </a:fld>
             <a:endParaRPr lang="en-US" dirty="0"/>
           </a:p>
@@ -11586,7 +11608,7 @@
           <a:p>
             <a:r>
               <a:rPr lang="en-US" dirty="0"/>
-              <a:t>The build process is started when you run the gulp task **build** from the command line:</a:t>
+              <a:t>The build process is started when you run the heft task **build** from the command line:</a:t>
             </a:r>
           </a:p>
           <a:p>
@@ -11601,7 +11623,7 @@
           <a:p>
             <a:r>
               <a:rPr lang="en-US" dirty="0"/>
-              <a:t>gulp build</a:t>
+              <a:t>heft build</a:t>
             </a:r>
           </a:p>
           <a:p>
@@ -11669,7 +11691,7 @@
           <a:p>
             <a:r>
               <a:rPr lang="en-US" dirty="0"/>
-              <a:t>The bundling process is started when you run the gulp task **bundle** from the command line. When you add the optional `--ship` or `-p` to the command, the bundling process will also minify the resulting bundle and manifest file. Minification removes all code comments and white space in the file to create the smallest possible file that's downloaded when the component is loaded on the page. The minified files are saved to the **./release/assets** folder.</a:t>
+              <a:t>The bundling process is handled as part of the build process and task. This changed when Microsoft switched from gulp to heft as the task runner. Previously, a separate gulp task was used to bundle the files. Minification removes all code comments and white space in the file to create the smallest possible file that's downloaded when the component is loaded on the page. The minified files are saved to the **./release/assets** folder.</a:t>
             </a:r>
           </a:p>
           <a:p>
@@ -11678,127 +11700,106 @@
           <a:p>
             <a:r>
               <a:rPr lang="en-US" dirty="0"/>
+              <a:t>### Package solution</a:t>
+            </a:r>
+          </a:p>
+          <a:p>
+            <a:endParaRPr lang="en-US" dirty="0"/>
+          </a:p>
+          <a:p>
+            <a:r>
+              <a:rPr lang="en-US" dirty="0"/>
+              <a:t>The last phase is packaging. The packaging phase generates all the files necessary to deploy your SharePoint Framework solution to SharePoint. These files are combined into a ZIP archive with a **</a:t>
+            </a:r>
+            <a:r>
+              <a:rPr lang="en-US" dirty="0" err="1"/>
+              <a:t>sppkg</a:t>
+            </a:r>
+            <a:r>
+              <a:rPr lang="en-US" dirty="0"/>
+              <a:t>** extension that's saved to the **./</a:t>
+            </a:r>
+            <a:r>
+              <a:rPr lang="en-US" dirty="0" err="1"/>
+              <a:t>sharepoint</a:t>
+            </a:r>
+            <a:r>
+              <a:rPr lang="en-US" dirty="0"/>
+              <a:t>/solution** folder in your project. This file is referred to as the *SharePoint package*.</a:t>
+            </a:r>
+          </a:p>
+          <a:p>
+            <a:endParaRPr lang="en-US" dirty="0"/>
+          </a:p>
+          <a:p>
+            <a:r>
+              <a:rPr lang="en-US" dirty="0"/>
+              <a:t>Before packaging all the files into the SharePoint package, the package solution phase generates multiple files necessary for deployment. This includes creating the app manifest, any feature definitions and element manifests necessary for provisioning the components, and collecting all the runtime files such as the bundle, component manifest and string localization files.</a:t>
+            </a:r>
+          </a:p>
+          <a:p>
+            <a:endParaRPr lang="en-US" dirty="0"/>
+          </a:p>
+          <a:p>
+            <a:r>
+              <a:rPr lang="en-US" dirty="0"/>
+              <a:t>Depending on the project configuration, the component runtime files including the bundle, component manifest, localization files, are placed in the **./release/assets** folder or added to the package. You can configure this setting using **./config/package-</a:t>
+            </a:r>
+            <a:r>
+              <a:rPr lang="en-US" dirty="0" err="1"/>
+              <a:t>solution.json</a:t>
+            </a:r>
+            <a:r>
+              <a:rPr lang="en-US" dirty="0"/>
+              <a:t>** file using the `</a:t>
+            </a:r>
+            <a:r>
+              <a:rPr lang="en-US" dirty="0" err="1"/>
+              <a:t>includeClientSideAssets</a:t>
+            </a:r>
+            <a:r>
+              <a:rPr lang="en-US" dirty="0"/>
+              <a:t>` property. When set to `true`, the files are added to the package and are automatically provisioned to the SharePoint library **</a:t>
+            </a:r>
+            <a:r>
+              <a:rPr lang="en-US" dirty="0" err="1"/>
+              <a:t>ClientSideAssets</a:t>
+            </a:r>
+            <a:r>
+              <a:rPr lang="en-US" dirty="0"/>
+              <a:t>** in the root of the site collection where the app is installed. Otherwise, when the property is set to `false`, you're responsible for deploying the files to a location your users can access, such as an Azure CDN.</a:t>
+            </a:r>
+          </a:p>
+          <a:p>
+            <a:endParaRPr lang="en-US" dirty="0"/>
+          </a:p>
+          <a:p>
+            <a:r>
+              <a:rPr lang="en-US" dirty="0"/>
+              <a:t>The packaging process is started when you run the heft task **package-solution** from the command line. When you add the optional `--production` or `-p` to the command, the packaging process will also modify manifest files for production, setting the URL where the component's runtime files can be located. This location is defined in the **./config/write-</a:t>
+            </a:r>
+            <a:r>
+              <a:rPr lang="en-US" dirty="0" err="1"/>
+              <a:t>manifests.json</a:t>
+            </a:r>
+            <a:r>
+              <a:rPr lang="en-US" dirty="0"/>
+              <a:t>** file.</a:t>
+            </a:r>
+          </a:p>
+          <a:p>
+            <a:endParaRPr lang="en-US" dirty="0"/>
+          </a:p>
+          <a:p>
+            <a:r>
+              <a:rPr lang="en-US" dirty="0"/>
               <a:t>```console</a:t>
             </a:r>
           </a:p>
           <a:p>
             <a:r>
               <a:rPr lang="en-US" dirty="0"/>
-              <a:t>gulp bundle</a:t>
-            </a:r>
-          </a:p>
-          <a:p>
-            <a:r>
-              <a:rPr lang="en-US" dirty="0"/>
-              <a:t>```</a:t>
-            </a:r>
-          </a:p>
-          <a:p>
-            <a:endParaRPr lang="en-US" dirty="0"/>
-          </a:p>
-          <a:p>
-            <a:r>
-              <a:rPr lang="en-US" dirty="0"/>
-              <a:t>### Package solution</a:t>
-            </a:r>
-          </a:p>
-          <a:p>
-            <a:endParaRPr lang="en-US" dirty="0"/>
-          </a:p>
-          <a:p>
-            <a:r>
-              <a:rPr lang="en-US" dirty="0"/>
-              <a:t>The last phase is packaging. The packaging phase generates all the files necessary to deploy your SharePoint Framework solution to SharePoint. These files are combined into a ZIP archive with a **</a:t>
-            </a:r>
-            <a:r>
-              <a:rPr lang="en-US" dirty="0" err="1"/>
-              <a:t>sppkg</a:t>
-            </a:r>
-            <a:r>
-              <a:rPr lang="en-US" dirty="0"/>
-              <a:t>** extension that's saved to the **./</a:t>
-            </a:r>
-            <a:r>
-              <a:rPr lang="en-US" dirty="0" err="1"/>
-              <a:t>sharepoint</a:t>
-            </a:r>
-            <a:r>
-              <a:rPr lang="en-US" dirty="0"/>
-              <a:t>/solution** folder in your project. This file is referred to as the *SharePoint package*.</a:t>
-            </a:r>
-          </a:p>
-          <a:p>
-            <a:endParaRPr lang="en-US" dirty="0"/>
-          </a:p>
-          <a:p>
-            <a:r>
-              <a:rPr lang="en-US" dirty="0"/>
-              <a:t>Before packaging all the files into the SharePoint package, the package solution phase generates multiple files necessary for deployment. This includes creating the app manifest, any feature definitions and element manifests necessary for provisioning the components, and collecting all the runtime files such as the bundle, component manifest and string localization files.</a:t>
-            </a:r>
-          </a:p>
-          <a:p>
-            <a:endParaRPr lang="en-US" dirty="0"/>
-          </a:p>
-          <a:p>
-            <a:r>
-              <a:rPr lang="en-US" dirty="0"/>
-              <a:t>Depending on the project configuration, the component runtime files including the bundle, component manifest, localization files, are placed in the **./release/assets** folder or added to the package. You can configure this setting using **./config/package-</a:t>
-            </a:r>
-            <a:r>
-              <a:rPr lang="en-US" dirty="0" err="1"/>
-              <a:t>solution.json</a:t>
-            </a:r>
-            <a:r>
-              <a:rPr lang="en-US" dirty="0"/>
-              <a:t>** file using the `</a:t>
-            </a:r>
-            <a:r>
-              <a:rPr lang="en-US" dirty="0" err="1"/>
-              <a:t>includeClientSideAssets</a:t>
-            </a:r>
-            <a:r>
-              <a:rPr lang="en-US" dirty="0"/>
-              <a:t>` property. When set to `true`, the files are added to the package and are automatically provisioned to the SharePoint library **</a:t>
-            </a:r>
-            <a:r>
-              <a:rPr lang="en-US" dirty="0" err="1"/>
-              <a:t>ClientSideAssets</a:t>
-            </a:r>
-            <a:r>
-              <a:rPr lang="en-US" dirty="0"/>
-              <a:t>** in the root of the site collection where the app is installed. Otherwise, when the property is set to `false`, you're responsible for deploying the files to a location your users can access, such as an Azure CDN.</a:t>
-            </a:r>
-          </a:p>
-          <a:p>
-            <a:endParaRPr lang="en-US" dirty="0"/>
-          </a:p>
-          <a:p>
-            <a:r>
-              <a:rPr lang="en-US" dirty="0"/>
-              <a:t>The packaging process is started when you run the gulp task **package-solution** from the command line. When you add the optional `--ship` or `-p` to the command, the packaging process will also modify manifest files for production, setting the URL where the component's runtime files can be located. This location is defined in the **./config/write-</a:t>
-            </a:r>
-            <a:r>
-              <a:rPr lang="en-US" dirty="0" err="1"/>
-              <a:t>manifests.json</a:t>
-            </a:r>
-            <a:r>
-              <a:rPr lang="en-US" dirty="0"/>
-              <a:t>** file.</a:t>
-            </a:r>
-          </a:p>
-          <a:p>
-            <a:endParaRPr lang="en-US" dirty="0"/>
-          </a:p>
-          <a:p>
-            <a:r>
-              <a:rPr lang="en-US" dirty="0"/>
-              <a:t>```console</a:t>
-            </a:r>
-          </a:p>
-          <a:p>
-            <a:r>
-              <a:rPr lang="en-US" dirty="0"/>
-              <a:t>gulp package-solution</a:t>
+              <a:t>heft package-solution</a:t>
             </a:r>
           </a:p>
           <a:p>
@@ -11906,7 +11907,7 @@
           <a:p>
             <a:fld id="{D18B56EA-E28F-4F92-9F16-7A6F2501B303}" type="datetime8">
               <a:rPr lang="en-US" smtClean="0"/>
-              <a:t>11/19/2022 4:11 PM</a:t>
+              <a:t>5/25/26 3:44 PM</a:t>
             </a:fld>
             <a:endParaRPr lang="en-US" dirty="0"/>
           </a:p>
@@ -11995,7 +11996,7 @@
           <a:p>
             <a:r>
               <a:rPr lang="en-US" dirty="0"/>
-              <a:t>In the previous section, you learned that two of the gulp tasks used in creating a SharePoint package support an optional `--ship` switch. This switch indicates you're bundling and packaging for production. When the switch isn't present, it indicates you're bundling and packaging for development or debugging.</a:t>
+              <a:t>In the previous section, you learned that two of the heft tasks used in creating a SharePoint package support an optional `--production` switch. This switch indicates you're bundling and packaging for production. When the switch isn't present, it indicates you're bundling and packaging for development or debugging.</a:t>
             </a:r>
           </a:p>
           <a:p>
@@ -12004,7 +12005,7 @@
           <a:p>
             <a:r>
               <a:rPr lang="en-US" dirty="0"/>
-              <a:t>The gulp **build** task doesn't have any switches, but both the **bundle** and **package-solution** tasks support the optional `--ship` switch. When running **bundle** and **package-solution**, make sure both either use or don't use the `--ship` switch. In other worse, don't use it on one and not the other.</a:t>
+              <a:t>The heft **build** task doesn't have any switches, but both the **bundle** and **package-solution** tasks support the optional `--production` switch. When running **bundle** and **package-solution**, make sure both either use or don't use the `--production` switch. In other worse, don't use it on one and not the other.</a:t>
             </a:r>
           </a:p>
           <a:p>
@@ -12209,7 +12210,7 @@
           <a:p>
             <a:fld id="{D18B56EA-E28F-4F92-9F16-7A6F2501B303}" type="datetime8">
               <a:rPr lang="en-US" smtClean="0"/>
-              <a:t>11/19/2022 4:11 PM</a:t>
+              <a:t>5/25/26 3:44 PM</a:t>
             </a:fld>
             <a:endParaRPr lang="en-US" dirty="0"/>
           </a:p>
@@ -12495,7 +12496,7 @@
           <a:p>
             <a:fld id="{D18B56EA-E28F-4F92-9F16-7A6F2501B303}" type="datetime8">
               <a:rPr lang="en-US" smtClean="0"/>
-              <a:t>11/19/2022 4:11 PM</a:t>
+              <a:t>5/25/26 3:44 PM</a:t>
             </a:fld>
             <a:endParaRPr lang="en-US" dirty="0"/>
           </a:p>
@@ -12733,7 +12734,7 @@
           <a:p>
             <a:fld id="{D18B56EA-E28F-4F92-9F16-7A6F2501B303}" type="datetime8">
               <a:rPr lang="en-US" smtClean="0"/>
-              <a:t>11/19/2022 4:11 PM</a:t>
+              <a:t>5/25/26 3:44 PM</a:t>
             </a:fld>
             <a:endParaRPr lang="en-US" dirty="0"/>
           </a:p>
@@ -12835,7 +12836,7 @@
             </a:pPr>
             <a:r>
               <a:rPr lang="en-US" dirty="0"/>
-              <a:t>Build the project: The first step is to build your project with the **gulp build** command. This will create all the files that are used in the deployment of your solution. </a:t>
+              <a:t>Build the project: The first step is to build your project with the **heft build** command. This will create all the files that are used in the deployment of your solution. </a:t>
             </a:r>
           </a:p>
           <a:p>
@@ -12845,7 +12846,7 @@
             </a:pPr>
             <a:r>
               <a:rPr lang="en-US" dirty="0"/>
-              <a:t>Generate the bundle and manifest: Next, create the component bundle and manifest files for production using the **gulp bundle --ship** command. This step takes the files from the build step and creates the files that will be deployed to SharePoint.</a:t>
+              <a:t>Generate the bundle and manifest: Next, create the component bundle and manifest files for production using the **heft bundle --production** command. This step takes the files from the build step and creates the files that will be deployed to SharePoint.</a:t>
             </a:r>
           </a:p>
           <a:p>
@@ -12855,7 +12856,7 @@
             </a:pPr>
             <a:r>
               <a:rPr lang="en-US" dirty="0"/>
-              <a:t>Generate the SharePoint package: The final step in the packaging process is to create the SharePoint package with the **gulp package-solution --ship** command. This step takes the results from the bundle phase, generates the necessary deployment files including an app manifest and associated feature files, and packages them into a single ZIP archive with a **</a:t>
+              <a:t>Generate the SharePoint package: The final step in the packaging process is to create the SharePoint package with the **heft package-solution --production** command. This step takes the results from the bundle phase, generates the necessary deployment files including an app manifest and associated feature files, and packages them into a single ZIP archive with a **</a:t>
             </a:r>
             <a:r>
               <a:rPr lang="en-US" dirty="0" err="1"/>
@@ -12985,7 +12986,7 @@
           <a:p>
             <a:fld id="{D18B56EA-E28F-4F92-9F16-7A6F2501B303}" type="datetime8">
               <a:rPr lang="en-US" smtClean="0"/>
-              <a:t>11/19/2022 4:11 PM</a:t>
+              <a:t>5/25/26 3:44 PM</a:t>
             </a:fld>
             <a:endParaRPr lang="en-US" dirty="0"/>
           </a:p>
@@ -13166,7 +13167,7 @@
           <a:p>
             <a:fld id="{D18B56EA-E28F-4F92-9F16-7A6F2501B303}" type="datetime8">
               <a:rPr lang="en-US" smtClean="0"/>
-              <a:t>11/19/2022 4:11 PM</a:t>
+              <a:t>5/25/26 3:44 PM</a:t>
             </a:fld>
             <a:endParaRPr lang="en-US" dirty="0"/>
           </a:p>
@@ -26395,13 +26396,22 @@
               </a:spcBef>
             </a:pPr>
             <a:r>
+              <a:rPr lang="en-US" sz="1600" b="0">
+                <a:solidFill>
+                  <a:srgbClr val="2F2F2F"/>
+                </a:solidFill>
+                <a:latin typeface="Segoe UI Semibold"/>
+              </a:rPr>
+              <a:t>Build </a:t>
+            </a:r>
+            <a:r>
               <a:rPr lang="en-US" sz="1600" b="0" dirty="0">
                 <a:solidFill>
                   <a:srgbClr val="2F2F2F"/>
                 </a:solidFill>
                 <a:latin typeface="Segoe UI Semibold"/>
               </a:rPr>
-              <a:t>Build, Bundle &amp; Ship</a:t>
+              <a:t>&amp; Ship</a:t>
             </a:r>
           </a:p>
           <a:p>
@@ -27038,7 +27048,7 @@
             </a:pPr>
             <a:r>
               <a:rPr lang="en-US" sz="2000" dirty="0"/>
-              <a:t>Build, Bundle &amp; Ship</a:t>
+              <a:t>Build &amp; Ship</a:t>
             </a:r>
           </a:p>
           <a:p>
@@ -27308,7 +27318,7 @@
           <p:nvPr>
             <p:extLst>
               <p:ext uri="{D42A27DB-BD31-4B8C-83A1-F6EECF244321}">
-                <p14:modId xmlns:p14="http://schemas.microsoft.com/office/powerpoint/2010/main" val="996724043"/>
+                <p14:modId xmlns:p14="http://schemas.microsoft.com/office/powerpoint/2010/main" val="2940893368"/>
               </p:ext>
             </p:extLst>
           </p:nvPr>
@@ -27773,7 +27783,7 @@
         <p:spPr>
           <a:xfrm>
             <a:off x="464400" y="1212850"/>
-            <a:ext cx="11574000" cy="5346079"/>
+            <a:ext cx="11574000" cy="4228850"/>
           </a:xfrm>
         </p:spPr>
         <p:txBody>
@@ -27792,7 +27802,7 @@
                 <a:latin typeface="Courier New" panose="02070309020205020404" pitchFamily="49" charset="0"/>
                 <a:cs typeface="Courier New" panose="02070309020205020404" pitchFamily="49" charset="0"/>
               </a:rPr>
-              <a:t>gulp build</a:t>
+              <a:t>heft build</a:t>
             </a:r>
           </a:p>
           <a:p>
@@ -27801,7 +27811,7 @@
           <a:p>
             <a:r>
               <a:rPr lang="en-US" dirty="0"/>
-              <a:t>Generate the bundle &amp; manifests</a:t>
+              <a:t>Generate the SharePoint package</a:t>
             </a:r>
           </a:p>
           <a:p>
@@ -27811,26 +27821,7 @@
                 <a:latin typeface="Courier New" panose="02070309020205020404" pitchFamily="49" charset="0"/>
                 <a:cs typeface="Courier New" panose="02070309020205020404" pitchFamily="49" charset="0"/>
               </a:rPr>
-              <a:t>gulp bundle --ship</a:t>
-            </a:r>
-          </a:p>
-          <a:p>
-            <a:endParaRPr lang="en-US" dirty="0"/>
-          </a:p>
-          <a:p>
-            <a:r>
-              <a:rPr lang="en-US" dirty="0"/>
-              <a:t>Generate the SharePoint package</a:t>
-            </a:r>
-          </a:p>
-          <a:p>
-            <a:pPr lvl="1"/>
-            <a:r>
-              <a:rPr lang="en-US" dirty="0">
-                <a:latin typeface="Courier New" panose="02070309020205020404" pitchFamily="49" charset="0"/>
-                <a:cs typeface="Courier New" panose="02070309020205020404" pitchFamily="49" charset="0"/>
-              </a:rPr>
-              <a:t>gulp package-solution –ship</a:t>
+              <a:t>heft package-solution –-production</a:t>
             </a:r>
           </a:p>
           <a:p>

</xml_diff>